<commit_message>
AWS UG Porto #8: joint-meetup visual on About, organizer photos + titles, 10% off on KCD slide
- Slide 2: AWS+OutSystems Porto hexagon (from Sources) as the About visual
- Slide 3: real organizer photos in identical circles (Meetup member photos for Fabio, Gabriel, Luiz;
  screenshot crops for Tiago, Ivan); titles: Organizer, Ivan = Event Organizer
- Slide 7: '10% off' shown next to the QR code with the discount code
- builder: About visual key, photo avatars, discount label; screenshot step tolerates Chrome timeouts

Co-Authored-By: Claude Fable 5.1 <noreply@anthropic.com>
</commit_message>
<xml_diff>
--- a/AWS UG Presentations/2026-09-08 - AWS UG Porto #8 x OutSystems UG Porto/2026-09-08-aws-ug-porto-8-x-outsystems-ug-porto.pptx
+++ b/AWS UG Presentations/2026-09-08 - AWS UG Porto #8 x OutSystems UG Porto/2026-09-08-aws-ug-porto-8-x-outsystems-ug-porto.pptx
@@ -4350,7 +4350,7 @@
       </p:sp>
       <p:pic>
         <p:nvPicPr>
-          <p:cNvPr id="7" name="Picture 6" descr="aws-ug-porto.jpg"/>
+          <p:cNvPr id="7" name="Picture 6" descr="aws-outsystems-porto.png"/>
           <p:cNvPicPr>
             <a:picLocks noChangeAspect="1"/>
           </p:cNvPicPr>
@@ -4364,8 +4364,8 @@
         </p:blipFill>
         <p:spPr>
           <a:xfrm>
-            <a:off x="813771" y="1828800"/>
-            <a:ext cx="4224617" cy="2286000"/>
+            <a:off x="1577339" y="1783079"/>
+            <a:ext cx="2697480" cy="2697480"/>
           </a:xfrm>
           <a:prstGeom prst="rect">
             <a:avLst/>
@@ -4380,8 +4380,8 @@
         </p:nvSpPr>
         <p:spPr>
           <a:xfrm>
-            <a:off x="868680" y="4251960"/>
-            <a:ext cx="4114800" cy="1783080"/>
+            <a:off x="868680" y="4617720"/>
+            <a:ext cx="4114800" cy="1417320"/>
           </a:xfrm>
           <a:prstGeom prst="rect">
             <a:avLst/>
@@ -4953,92 +4953,33 @@
           <a:p/>
         </p:txBody>
       </p:sp>
-      <p:sp>
-        <p:nvSpPr>
-          <p:cNvPr id="7" name="Oval 6"/>
-          <p:cNvSpPr/>
-          <p:nvPr/>
-        </p:nvSpPr>
+      <p:pic>
+        <p:nvPicPr>
+          <p:cNvPr id="7" name="Picture 6" descr="org-fabio-sampaio-1badea5deb.png"/>
+          <p:cNvPicPr>
+            <a:picLocks noChangeAspect="1"/>
+          </p:cNvPicPr>
+          <p:nvPr/>
+        </p:nvPicPr>
+        <p:blipFill>
+          <a:blip r:embed="rId3"/>
+          <a:stretch>
+            <a:fillRect/>
+          </a:stretch>
+        </p:blipFill>
         <p:spPr>
           <a:xfrm>
             <a:off x="1027785" y="2263139"/>
             <a:ext cx="1143000" cy="1143000"/>
           </a:xfrm>
-          <a:prstGeom prst="ellipse">
-            <a:avLst/>
-          </a:prstGeom>
-          <a:solidFill>
-            <a:srgbClr val="45307F"/>
-          </a:solidFill>
-          <a:ln>
-            <a:noFill/>
-          </a:ln>
-          <a:effectLst/>
-        </p:spPr>
-        <p:style>
-          <a:lnRef idx="1">
-            <a:schemeClr val="accent1"/>
-          </a:lnRef>
-          <a:fillRef idx="3">
-            <a:schemeClr val="accent1"/>
-          </a:fillRef>
-          <a:effectRef idx="2">
-            <a:schemeClr val="accent1"/>
-          </a:effectRef>
-          <a:fontRef idx="minor">
-            <a:schemeClr val="lt1"/>
-          </a:fontRef>
-        </p:style>
-        <p:txBody>
-          <a:bodyPr rtlCol="0" anchor="ctr"/>
-          <a:lstStyle/>
-          <a:p>
-            <a:pPr algn="ctr"/>
-          </a:p>
-        </p:txBody>
-      </p:sp>
+          <a:prstGeom prst="rect">
+            <a:avLst/>
+          </a:prstGeom>
+        </p:spPr>
+      </p:pic>
       <p:sp>
         <p:nvSpPr>
           <p:cNvPr id="8" name="TextBox 7"/>
-          <p:cNvSpPr txBox="1"/>
-          <p:nvPr/>
-        </p:nvSpPr>
-        <p:spPr>
-          <a:xfrm>
-            <a:off x="1027785" y="2263139"/>
-            <a:ext cx="1143000" cy="1143000"/>
-          </a:xfrm>
-          <a:prstGeom prst="rect">
-            <a:avLst/>
-          </a:prstGeom>
-          <a:noFill/>
-        </p:spPr>
-        <p:txBody>
-          <a:bodyPr wrap="square" lIns="0" rIns="0" tIns="0" bIns="0" anchor="ctr">
-            <a:noAutofit/>
-          </a:bodyPr>
-          <a:lstStyle/>
-          <a:p>
-            <a:pPr algn="ctr">
-              <a:lnSpc>
-                <a:spcPct val="100000"/>
-              </a:lnSpc>
-            </a:pPr>
-            <a:r>
-              <a:rPr b="1" i="0" sz="2750">
-                <a:solidFill>
-                  <a:srgbClr val="FFFFFF"/>
-                </a:solidFill>
-                <a:latin typeface="Poppins"/>
-              </a:rPr>
-              <a:t>FS</a:t>
-            </a:r>
-          </a:p>
-        </p:txBody>
-      </p:sp>
-      <p:sp>
-        <p:nvSpPr>
-          <p:cNvPr id="9" name="TextBox 8"/>
           <p:cNvSpPr txBox="1"/>
           <p:nvPr/>
         </p:nvSpPr>
@@ -5077,7 +5018,7 @@
       </p:sp>
       <p:sp>
         <p:nvSpPr>
-          <p:cNvPr id="10" name="Rounded Rectangle 9"/>
+          <p:cNvPr id="9" name="Rounded Rectangle 8"/>
           <p:cNvSpPr/>
           <p:nvPr/>
         </p:nvSpPr>
@@ -5121,7 +5062,7 @@
       </p:sp>
       <p:sp>
         <p:nvSpPr>
-          <p:cNvPr id="11" name="TextBox 10"/>
+          <p:cNvPr id="10" name="TextBox 9"/>
           <p:cNvSpPr txBox="1"/>
           <p:nvPr/>
         </p:nvSpPr>
@@ -5160,7 +5101,7 @@
       </p:sp>
       <p:sp>
         <p:nvSpPr>
-          <p:cNvPr id="12" name="Rounded Rectangle 11"/>
+          <p:cNvPr id="11" name="Rounded Rectangle 10"/>
           <p:cNvSpPr/>
           <p:nvPr/>
         </p:nvSpPr>
@@ -5204,7 +5145,7 @@
       </p:sp>
       <p:sp>
         <p:nvSpPr>
-          <p:cNvPr id="13" name="TextBox 12"/>
+          <p:cNvPr id="12" name="TextBox 11"/>
           <p:cNvSpPr txBox="1"/>
           <p:nvPr/>
         </p:nvSpPr>
@@ -5243,7 +5184,7 @@
       </p:sp>
       <p:sp>
         <p:nvSpPr>
-          <p:cNvPr id="14" name="Rounded Rectangle 13"/>
+          <p:cNvPr id="13" name="Rounded Rectangle 12"/>
           <p:cNvSpPr/>
           <p:nvPr/>
         </p:nvSpPr>
@@ -5285,92 +5226,33 @@
           <a:p/>
         </p:txBody>
       </p:sp>
-      <p:sp>
-        <p:nvSpPr>
-          <p:cNvPr id="15" name="Oval 14"/>
-          <p:cNvSpPr/>
-          <p:nvPr/>
-        </p:nvSpPr>
+      <p:pic>
+        <p:nvPicPr>
+          <p:cNvPr id="14" name="Picture 13" descr="org-gabriel-alves-4631b3617e.png"/>
+          <p:cNvPicPr>
+            <a:picLocks noChangeAspect="1"/>
+          </p:cNvPicPr>
+          <p:nvPr/>
+        </p:nvPicPr>
+        <p:blipFill>
+          <a:blip r:embed="rId4"/>
+          <a:stretch>
+            <a:fillRect/>
+          </a:stretch>
+        </p:blipFill>
         <p:spPr>
           <a:xfrm>
             <a:off x="3275380" y="2263139"/>
             <a:ext cx="1143000" cy="1143000"/>
           </a:xfrm>
-          <a:prstGeom prst="ellipse">
-            <a:avLst/>
-          </a:prstGeom>
-          <a:solidFill>
-            <a:srgbClr val="45307F"/>
-          </a:solidFill>
-          <a:ln>
-            <a:noFill/>
-          </a:ln>
-          <a:effectLst/>
-        </p:spPr>
-        <p:style>
-          <a:lnRef idx="1">
-            <a:schemeClr val="accent1"/>
-          </a:lnRef>
-          <a:fillRef idx="3">
-            <a:schemeClr val="accent1"/>
-          </a:fillRef>
-          <a:effectRef idx="2">
-            <a:schemeClr val="accent1"/>
-          </a:effectRef>
-          <a:fontRef idx="minor">
-            <a:schemeClr val="lt1"/>
-          </a:fontRef>
-        </p:style>
-        <p:txBody>
-          <a:bodyPr rtlCol="0" anchor="ctr"/>
-          <a:lstStyle/>
-          <a:p>
-            <a:pPr algn="ctr"/>
-          </a:p>
-        </p:txBody>
-      </p:sp>
-      <p:sp>
-        <p:nvSpPr>
-          <p:cNvPr id="16" name="TextBox 15"/>
-          <p:cNvSpPr txBox="1"/>
-          <p:nvPr/>
-        </p:nvSpPr>
-        <p:spPr>
-          <a:xfrm>
-            <a:off x="3275380" y="2263139"/>
-            <a:ext cx="1143000" cy="1143000"/>
-          </a:xfrm>
-          <a:prstGeom prst="rect">
-            <a:avLst/>
-          </a:prstGeom>
-          <a:noFill/>
-        </p:spPr>
-        <p:txBody>
-          <a:bodyPr wrap="square" lIns="0" rIns="0" tIns="0" bIns="0" anchor="ctr">
-            <a:noAutofit/>
-          </a:bodyPr>
-          <a:lstStyle/>
-          <a:p>
-            <a:pPr algn="ctr">
-              <a:lnSpc>
-                <a:spcPct val="100000"/>
-              </a:lnSpc>
-            </a:pPr>
-            <a:r>
-              <a:rPr b="1" i="0" sz="2750">
-                <a:solidFill>
-                  <a:srgbClr val="FFFFFF"/>
-                </a:solidFill>
-                <a:latin typeface="Poppins"/>
-              </a:rPr>
-              <a:t>GA</a:t>
-            </a:r>
-          </a:p>
-        </p:txBody>
-      </p:sp>
-      <p:sp>
-        <p:nvSpPr>
-          <p:cNvPr id="17" name="TextBox 16"/>
+          <a:prstGeom prst="rect">
+            <a:avLst/>
+          </a:prstGeom>
+        </p:spPr>
+      </p:pic>
+      <p:sp>
+        <p:nvSpPr>
+          <p:cNvPr id="15" name="TextBox 14"/>
           <p:cNvSpPr txBox="1"/>
           <p:nvPr/>
         </p:nvSpPr>
@@ -5409,14 +5291,14 @@
       </p:sp>
       <p:sp>
         <p:nvSpPr>
-          <p:cNvPr id="18" name="Rounded Rectangle 17"/>
+          <p:cNvPr id="16" name="Rounded Rectangle 15"/>
           <p:cNvSpPr/>
           <p:nvPr/>
         </p:nvSpPr>
         <p:spPr>
           <a:xfrm>
-            <a:off x="3259429" y="4343400"/>
-            <a:ext cx="1174902" cy="329184"/>
+            <a:off x="3370554" y="4343400"/>
+            <a:ext cx="952652" cy="329184"/>
           </a:xfrm>
           <a:prstGeom prst="roundRect">
             <a:avLst>
@@ -5453,14 +5335,14 @@
       </p:sp>
       <p:sp>
         <p:nvSpPr>
-          <p:cNvPr id="19" name="TextBox 18"/>
+          <p:cNvPr id="17" name="TextBox 16"/>
           <p:cNvSpPr txBox="1"/>
           <p:nvPr/>
         </p:nvSpPr>
         <p:spPr>
           <a:xfrm>
-            <a:off x="3259429" y="4343400"/>
-            <a:ext cx="1174902" cy="329184"/>
+            <a:off x="3370554" y="4343400"/>
+            <a:ext cx="952652" cy="329184"/>
           </a:xfrm>
           <a:prstGeom prst="rect">
             <a:avLst/>
@@ -5485,14 +5367,14 @@
                 </a:solidFill>
                 <a:latin typeface="Poppins Medium"/>
               </a:rPr>
-              <a:t>Co-organizer</a:t>
-            </a:r>
-          </a:p>
-        </p:txBody>
-      </p:sp>
-      <p:sp>
-        <p:nvSpPr>
-          <p:cNvPr id="20" name="Rounded Rectangle 19"/>
+              <a:t>Organizer</a:t>
+            </a:r>
+          </a:p>
+        </p:txBody>
+      </p:sp>
+      <p:sp>
+        <p:nvSpPr>
+          <p:cNvPr id="18" name="Rounded Rectangle 17"/>
           <p:cNvSpPr/>
           <p:nvPr/>
         </p:nvSpPr>
@@ -5536,7 +5418,7 @@
       </p:sp>
       <p:sp>
         <p:nvSpPr>
-          <p:cNvPr id="21" name="TextBox 20"/>
+          <p:cNvPr id="19" name="TextBox 18"/>
           <p:cNvSpPr txBox="1"/>
           <p:nvPr/>
         </p:nvSpPr>
@@ -5575,7 +5457,7 @@
       </p:sp>
       <p:sp>
         <p:nvSpPr>
-          <p:cNvPr id="22" name="Rounded Rectangle 21"/>
+          <p:cNvPr id="20" name="Rounded Rectangle 19"/>
           <p:cNvSpPr/>
           <p:nvPr/>
         </p:nvSpPr>
@@ -5617,92 +5499,33 @@
           <a:p/>
         </p:txBody>
       </p:sp>
-      <p:sp>
-        <p:nvSpPr>
-          <p:cNvPr id="23" name="Oval 22"/>
-          <p:cNvSpPr/>
-          <p:nvPr/>
-        </p:nvSpPr>
+      <p:pic>
+        <p:nvPicPr>
+          <p:cNvPr id="21" name="Picture 20" descr="org-luiz-rodrigues-4af93c140b.png"/>
+          <p:cNvPicPr>
+            <a:picLocks noChangeAspect="1"/>
+          </p:cNvPicPr>
+          <p:nvPr/>
+        </p:nvPicPr>
+        <p:blipFill>
+          <a:blip r:embed="rId5"/>
+          <a:stretch>
+            <a:fillRect/>
+          </a:stretch>
+        </p:blipFill>
         <p:spPr>
           <a:xfrm>
             <a:off x="5522976" y="2263139"/>
             <a:ext cx="1143000" cy="1143000"/>
           </a:xfrm>
-          <a:prstGeom prst="ellipse">
-            <a:avLst/>
-          </a:prstGeom>
-          <a:solidFill>
-            <a:srgbClr val="45307F"/>
-          </a:solidFill>
-          <a:ln>
-            <a:noFill/>
-          </a:ln>
-          <a:effectLst/>
-        </p:spPr>
-        <p:style>
-          <a:lnRef idx="1">
-            <a:schemeClr val="accent1"/>
-          </a:lnRef>
-          <a:fillRef idx="3">
-            <a:schemeClr val="accent1"/>
-          </a:fillRef>
-          <a:effectRef idx="2">
-            <a:schemeClr val="accent1"/>
-          </a:effectRef>
-          <a:fontRef idx="minor">
-            <a:schemeClr val="lt1"/>
-          </a:fontRef>
-        </p:style>
-        <p:txBody>
-          <a:bodyPr rtlCol="0" anchor="ctr"/>
-          <a:lstStyle/>
-          <a:p>
-            <a:pPr algn="ctr"/>
-          </a:p>
-        </p:txBody>
-      </p:sp>
-      <p:sp>
-        <p:nvSpPr>
-          <p:cNvPr id="24" name="TextBox 23"/>
-          <p:cNvSpPr txBox="1"/>
-          <p:nvPr/>
-        </p:nvSpPr>
-        <p:spPr>
-          <a:xfrm>
-            <a:off x="5522976" y="2263139"/>
-            <a:ext cx="1143000" cy="1143000"/>
-          </a:xfrm>
-          <a:prstGeom prst="rect">
-            <a:avLst/>
-          </a:prstGeom>
-          <a:noFill/>
-        </p:spPr>
-        <p:txBody>
-          <a:bodyPr wrap="square" lIns="0" rIns="0" tIns="0" bIns="0" anchor="ctr">
-            <a:noAutofit/>
-          </a:bodyPr>
-          <a:lstStyle/>
-          <a:p>
-            <a:pPr algn="ctr">
-              <a:lnSpc>
-                <a:spcPct val="100000"/>
-              </a:lnSpc>
-            </a:pPr>
-            <a:r>
-              <a:rPr b="1" i="0" sz="2750">
-                <a:solidFill>
-                  <a:srgbClr val="FFFFFF"/>
-                </a:solidFill>
-                <a:latin typeface="Poppins"/>
-              </a:rPr>
-              <a:t>LR</a:t>
-            </a:r>
-          </a:p>
-        </p:txBody>
-      </p:sp>
-      <p:sp>
-        <p:nvSpPr>
-          <p:cNvPr id="25" name="TextBox 24"/>
+          <a:prstGeom prst="rect">
+            <a:avLst/>
+          </a:prstGeom>
+        </p:spPr>
+      </p:pic>
+      <p:sp>
+        <p:nvSpPr>
+          <p:cNvPr id="22" name="TextBox 21"/>
           <p:cNvSpPr txBox="1"/>
           <p:nvPr/>
         </p:nvSpPr>
@@ -5741,14 +5564,14 @@
       </p:sp>
       <p:sp>
         <p:nvSpPr>
-          <p:cNvPr id="26" name="Rounded Rectangle 25"/>
+          <p:cNvPr id="23" name="Rounded Rectangle 22"/>
           <p:cNvSpPr/>
           <p:nvPr/>
         </p:nvSpPr>
         <p:spPr>
           <a:xfrm>
-            <a:off x="5445112" y="4343400"/>
-            <a:ext cx="1298727" cy="329184"/>
+            <a:off x="5618149" y="4343400"/>
+            <a:ext cx="952652" cy="329184"/>
           </a:xfrm>
           <a:prstGeom prst="roundRect">
             <a:avLst>
@@ -5785,14 +5608,14 @@
       </p:sp>
       <p:sp>
         <p:nvSpPr>
-          <p:cNvPr id="27" name="TextBox 26"/>
+          <p:cNvPr id="24" name="TextBox 23"/>
           <p:cNvSpPr txBox="1"/>
           <p:nvPr/>
         </p:nvSpPr>
         <p:spPr>
           <a:xfrm>
-            <a:off x="5445112" y="4343400"/>
-            <a:ext cx="1298727" cy="329184"/>
+            <a:off x="5618149" y="4343400"/>
+            <a:ext cx="952652" cy="329184"/>
           </a:xfrm>
           <a:prstGeom prst="rect">
             <a:avLst/>
@@ -5817,14 +5640,14 @@
                 </a:solidFill>
                 <a:latin typeface="Poppins Medium"/>
               </a:rPr>
-              <a:t>Event organizer</a:t>
-            </a:r>
-          </a:p>
-        </p:txBody>
-      </p:sp>
-      <p:sp>
-        <p:nvSpPr>
-          <p:cNvPr id="28" name="Rounded Rectangle 27"/>
+              <a:t>Organizer</a:t>
+            </a:r>
+          </a:p>
+        </p:txBody>
+      </p:sp>
+      <p:sp>
+        <p:nvSpPr>
+          <p:cNvPr id="25" name="Rounded Rectangle 24"/>
           <p:cNvSpPr/>
           <p:nvPr/>
         </p:nvSpPr>
@@ -5868,7 +5691,7 @@
       </p:sp>
       <p:sp>
         <p:nvSpPr>
-          <p:cNvPr id="29" name="TextBox 28"/>
+          <p:cNvPr id="26" name="TextBox 25"/>
           <p:cNvSpPr txBox="1"/>
           <p:nvPr/>
         </p:nvSpPr>
@@ -5907,7 +5730,7 @@
       </p:sp>
       <p:sp>
         <p:nvSpPr>
-          <p:cNvPr id="30" name="Rounded Rectangle 29"/>
+          <p:cNvPr id="27" name="Rounded Rectangle 26"/>
           <p:cNvSpPr/>
           <p:nvPr/>
         </p:nvSpPr>
@@ -5949,92 +5772,33 @@
           <a:p/>
         </p:txBody>
       </p:sp>
-      <p:sp>
-        <p:nvSpPr>
-          <p:cNvPr id="31" name="Oval 30"/>
-          <p:cNvSpPr/>
-          <p:nvPr/>
-        </p:nvSpPr>
+      <p:pic>
+        <p:nvPicPr>
+          <p:cNvPr id="28" name="Picture 27" descr="org-tiago-rodrigues-52d5d646c0.png"/>
+          <p:cNvPicPr>
+            <a:picLocks noChangeAspect="1"/>
+          </p:cNvPicPr>
+          <p:nvPr/>
+        </p:nvPicPr>
+        <p:blipFill>
+          <a:blip r:embed="rId6"/>
+          <a:stretch>
+            <a:fillRect/>
+          </a:stretch>
+        </p:blipFill>
         <p:spPr>
           <a:xfrm>
             <a:off x="7770571" y="2263139"/>
             <a:ext cx="1143000" cy="1143000"/>
           </a:xfrm>
-          <a:prstGeom prst="ellipse">
-            <a:avLst/>
-          </a:prstGeom>
-          <a:solidFill>
-            <a:srgbClr val="45307F"/>
-          </a:solidFill>
-          <a:ln>
-            <a:noFill/>
-          </a:ln>
-          <a:effectLst/>
-        </p:spPr>
-        <p:style>
-          <a:lnRef idx="1">
-            <a:schemeClr val="accent1"/>
-          </a:lnRef>
-          <a:fillRef idx="3">
-            <a:schemeClr val="accent1"/>
-          </a:fillRef>
-          <a:effectRef idx="2">
-            <a:schemeClr val="accent1"/>
-          </a:effectRef>
-          <a:fontRef idx="minor">
-            <a:schemeClr val="lt1"/>
-          </a:fontRef>
-        </p:style>
-        <p:txBody>
-          <a:bodyPr rtlCol="0" anchor="ctr"/>
-          <a:lstStyle/>
-          <a:p>
-            <a:pPr algn="ctr"/>
-          </a:p>
-        </p:txBody>
-      </p:sp>
-      <p:sp>
-        <p:nvSpPr>
-          <p:cNvPr id="32" name="TextBox 31"/>
-          <p:cNvSpPr txBox="1"/>
-          <p:nvPr/>
-        </p:nvSpPr>
-        <p:spPr>
-          <a:xfrm>
-            <a:off x="7770571" y="2263139"/>
-            <a:ext cx="1143000" cy="1143000"/>
-          </a:xfrm>
-          <a:prstGeom prst="rect">
-            <a:avLst/>
-          </a:prstGeom>
-          <a:noFill/>
-        </p:spPr>
-        <p:txBody>
-          <a:bodyPr wrap="square" lIns="0" rIns="0" tIns="0" bIns="0" anchor="ctr">
-            <a:noAutofit/>
-          </a:bodyPr>
-          <a:lstStyle/>
-          <a:p>
-            <a:pPr algn="ctr">
-              <a:lnSpc>
-                <a:spcPct val="100000"/>
-              </a:lnSpc>
-            </a:pPr>
-            <a:r>
-              <a:rPr b="1" i="0" sz="2750">
-                <a:solidFill>
-                  <a:srgbClr val="FFFFFF"/>
-                </a:solidFill>
-                <a:latin typeface="Poppins"/>
-              </a:rPr>
-              <a:t>TR</a:t>
-            </a:r>
-          </a:p>
-        </p:txBody>
-      </p:sp>
-      <p:sp>
-        <p:nvSpPr>
-          <p:cNvPr id="33" name="TextBox 32"/>
+          <a:prstGeom prst="rect">
+            <a:avLst/>
+          </a:prstGeom>
+        </p:spPr>
+      </p:pic>
+      <p:sp>
+        <p:nvSpPr>
+          <p:cNvPr id="29" name="TextBox 28"/>
           <p:cNvSpPr txBox="1"/>
           <p:nvPr/>
         </p:nvSpPr>
@@ -6073,14 +5837,14 @@
       </p:sp>
       <p:sp>
         <p:nvSpPr>
-          <p:cNvPr id="34" name="Rounded Rectangle 33"/>
+          <p:cNvPr id="30" name="Rounded Rectangle 29"/>
           <p:cNvSpPr/>
           <p:nvPr/>
         </p:nvSpPr>
         <p:spPr>
           <a:xfrm>
-            <a:off x="7754620" y="4343400"/>
-            <a:ext cx="1174902" cy="329184"/>
+            <a:off x="7865745" y="4343400"/>
+            <a:ext cx="952652" cy="329184"/>
           </a:xfrm>
           <a:prstGeom prst="roundRect">
             <a:avLst>
@@ -6117,14 +5881,14 @@
       </p:sp>
       <p:sp>
         <p:nvSpPr>
-          <p:cNvPr id="35" name="TextBox 34"/>
+          <p:cNvPr id="31" name="TextBox 30"/>
           <p:cNvSpPr txBox="1"/>
           <p:nvPr/>
         </p:nvSpPr>
         <p:spPr>
           <a:xfrm>
-            <a:off x="7754620" y="4343400"/>
-            <a:ext cx="1174902" cy="329184"/>
+            <a:off x="7865745" y="4343400"/>
+            <a:ext cx="952652" cy="329184"/>
           </a:xfrm>
           <a:prstGeom prst="rect">
             <a:avLst/>
@@ -6149,14 +5913,14 @@
                 </a:solidFill>
                 <a:latin typeface="Poppins Medium"/>
               </a:rPr>
-              <a:t>Co-organizer</a:t>
-            </a:r>
-          </a:p>
-        </p:txBody>
-      </p:sp>
-      <p:sp>
-        <p:nvSpPr>
-          <p:cNvPr id="36" name="Rounded Rectangle 35"/>
+              <a:t>Organizer</a:t>
+            </a:r>
+          </a:p>
+        </p:txBody>
+      </p:sp>
+      <p:sp>
+        <p:nvSpPr>
+          <p:cNvPr id="32" name="Rounded Rectangle 31"/>
           <p:cNvSpPr/>
           <p:nvPr/>
         </p:nvSpPr>
@@ -6198,92 +5962,33 @@
           <a:p/>
         </p:txBody>
       </p:sp>
-      <p:sp>
-        <p:nvSpPr>
-          <p:cNvPr id="37" name="Oval 36"/>
-          <p:cNvSpPr/>
-          <p:nvPr/>
-        </p:nvSpPr>
+      <p:pic>
+        <p:nvPicPr>
+          <p:cNvPr id="33" name="Picture 32" descr="org-ivan-ferreira-850ce7d7f2.png"/>
+          <p:cNvPicPr>
+            <a:picLocks noChangeAspect="1"/>
+          </p:cNvPicPr>
+          <p:nvPr/>
+        </p:nvPicPr>
+        <p:blipFill>
+          <a:blip r:embed="rId7"/>
+          <a:stretch>
+            <a:fillRect/>
+          </a:stretch>
+        </p:blipFill>
         <p:spPr>
           <a:xfrm>
             <a:off x="10018166" y="2263139"/>
             <a:ext cx="1143000" cy="1143000"/>
           </a:xfrm>
-          <a:prstGeom prst="ellipse">
-            <a:avLst/>
-          </a:prstGeom>
-          <a:solidFill>
-            <a:srgbClr val="45307F"/>
-          </a:solidFill>
-          <a:ln>
-            <a:noFill/>
-          </a:ln>
-          <a:effectLst/>
-        </p:spPr>
-        <p:style>
-          <a:lnRef idx="1">
-            <a:schemeClr val="accent1"/>
-          </a:lnRef>
-          <a:fillRef idx="3">
-            <a:schemeClr val="accent1"/>
-          </a:fillRef>
-          <a:effectRef idx="2">
-            <a:schemeClr val="accent1"/>
-          </a:effectRef>
-          <a:fontRef idx="minor">
-            <a:schemeClr val="lt1"/>
-          </a:fontRef>
-        </p:style>
-        <p:txBody>
-          <a:bodyPr rtlCol="0" anchor="ctr"/>
-          <a:lstStyle/>
-          <a:p>
-            <a:pPr algn="ctr"/>
-          </a:p>
-        </p:txBody>
-      </p:sp>
-      <p:sp>
-        <p:nvSpPr>
-          <p:cNvPr id="38" name="TextBox 37"/>
-          <p:cNvSpPr txBox="1"/>
-          <p:nvPr/>
-        </p:nvSpPr>
-        <p:spPr>
-          <a:xfrm>
-            <a:off x="10018166" y="2263139"/>
-            <a:ext cx="1143000" cy="1143000"/>
-          </a:xfrm>
-          <a:prstGeom prst="rect">
-            <a:avLst/>
-          </a:prstGeom>
-          <a:noFill/>
-        </p:spPr>
-        <p:txBody>
-          <a:bodyPr wrap="square" lIns="0" rIns="0" tIns="0" bIns="0" anchor="ctr">
-            <a:noAutofit/>
-          </a:bodyPr>
-          <a:lstStyle/>
-          <a:p>
-            <a:pPr algn="ctr">
-              <a:lnSpc>
-                <a:spcPct val="100000"/>
-              </a:lnSpc>
-            </a:pPr>
-            <a:r>
-              <a:rPr b="1" i="0" sz="2750">
-                <a:solidFill>
-                  <a:srgbClr val="FFFFFF"/>
-                </a:solidFill>
-                <a:latin typeface="Poppins"/>
-              </a:rPr>
-              <a:t>IF</a:t>
-            </a:r>
-          </a:p>
-        </p:txBody>
-      </p:sp>
-      <p:sp>
-        <p:nvSpPr>
-          <p:cNvPr id="39" name="TextBox 38"/>
+          <a:prstGeom prst="rect">
+            <a:avLst/>
+          </a:prstGeom>
+        </p:spPr>
+      </p:pic>
+      <p:sp>
+        <p:nvSpPr>
+          <p:cNvPr id="34" name="TextBox 33"/>
           <p:cNvSpPr txBox="1"/>
           <p:nvPr/>
         </p:nvSpPr>
@@ -6322,14 +6027,14 @@
       </p:sp>
       <p:sp>
         <p:nvSpPr>
-          <p:cNvPr id="40" name="Rounded Rectangle 39"/>
+          <p:cNvPr id="35" name="Rounded Rectangle 34"/>
           <p:cNvSpPr/>
           <p:nvPr/>
         </p:nvSpPr>
         <p:spPr>
           <a:xfrm>
-            <a:off x="9900615" y="4343400"/>
-            <a:ext cx="1378102" cy="329184"/>
+            <a:off x="9932365" y="4343400"/>
+            <a:ext cx="1314602" cy="329184"/>
           </a:xfrm>
           <a:prstGeom prst="roundRect">
             <a:avLst>
@@ -6366,14 +6071,14 @@
       </p:sp>
       <p:sp>
         <p:nvSpPr>
-          <p:cNvPr id="41" name="TextBox 40"/>
+          <p:cNvPr id="36" name="TextBox 35"/>
           <p:cNvSpPr txBox="1"/>
           <p:nvPr/>
         </p:nvSpPr>
         <p:spPr>
           <a:xfrm>
-            <a:off x="9900615" y="4343400"/>
-            <a:ext cx="1378102" cy="329184"/>
+            <a:off x="9932365" y="4343400"/>
+            <a:ext cx="1314602" cy="329184"/>
           </a:xfrm>
           <a:prstGeom prst="rect">
             <a:avLst/>
@@ -6398,14 +6103,14 @@
                 </a:solidFill>
                 <a:latin typeface="Poppins Medium"/>
               </a:rPr>
-              <a:t>Leadership team</a:t>
-            </a:r>
-          </a:p>
-        </p:txBody>
-      </p:sp>
-      <p:sp>
-        <p:nvSpPr>
-          <p:cNvPr id="42" name="TextBox 41"/>
+              <a:t>Event Organizer</a:t>
+            </a:r>
+          </a:p>
+        </p:txBody>
+      </p:sp>
+      <p:sp>
+        <p:nvSpPr>
+          <p:cNvPr id="37" name="TextBox 36"/>
           <p:cNvSpPr txBox="1"/>
           <p:nvPr/>
         </p:nvSpPr>
@@ -6444,7 +6149,7 @@
       </p:sp>
       <p:sp>
         <p:nvSpPr>
-          <p:cNvPr id="43" name="TextBox 42"/>
+          <p:cNvPr id="38" name="TextBox 37"/>
           <p:cNvSpPr txBox="1"/>
           <p:nvPr/>
         </p:nvSpPr>
@@ -6483,7 +6188,7 @@
       </p:sp>
       <p:sp>
         <p:nvSpPr>
-          <p:cNvPr id="44" name="TextBox 43"/>
+          <p:cNvPr id="39" name="TextBox 38"/>
           <p:cNvSpPr txBox="1"/>
           <p:nvPr/>
         </p:nvSpPr>
@@ -10692,8 +10397,8 @@
         </p:blipFill>
         <p:spPr>
           <a:xfrm>
-            <a:off x="8586216" y="1691640"/>
-            <a:ext cx="2514600" cy="2514600"/>
+            <a:off x="8677656" y="1691640"/>
+            <a:ext cx="2331720" cy="2331720"/>
           </a:xfrm>
           <a:prstGeom prst="rect">
             <a:avLst/>
@@ -10708,8 +10413,8 @@
         </p:nvSpPr>
         <p:spPr>
           <a:xfrm>
-            <a:off x="8183879" y="4224528"/>
-            <a:ext cx="3319272" cy="320040"/>
+            <a:off x="8183879" y="4050791"/>
+            <a:ext cx="3319272" cy="301752"/>
           </a:xfrm>
           <a:prstGeom prst="rect">
             <a:avLst/>
@@ -10747,8 +10452,47 @@
         </p:nvSpPr>
         <p:spPr>
           <a:xfrm>
-            <a:off x="8183879" y="4645152"/>
-            <a:ext cx="3319272" cy="274320"/>
+            <a:off x="8183879" y="4407408"/>
+            <a:ext cx="3319272" cy="548640"/>
+          </a:xfrm>
+          <a:prstGeom prst="rect">
+            <a:avLst/>
+          </a:prstGeom>
+          <a:noFill/>
+        </p:spPr>
+        <p:txBody>
+          <a:bodyPr wrap="square" lIns="0" rIns="0" tIns="0" bIns="0" anchor="ctr">
+            <a:noAutofit/>
+          </a:bodyPr>
+          <a:lstStyle/>
+          <a:p>
+            <a:pPr algn="ctr">
+              <a:lnSpc>
+                <a:spcPct val="95000"/>
+              </a:lnSpc>
+            </a:pPr>
+            <a:r>
+              <a:rPr b="1" i="0" sz="3000">
+                <a:solidFill>
+                  <a:srgbClr val="45307F"/>
+                </a:solidFill>
+                <a:latin typeface="Poppins"/>
+              </a:rPr>
+              <a:t>10% off</a:t>
+            </a:r>
+          </a:p>
+        </p:txBody>
+      </p:sp>
+      <p:sp>
+        <p:nvSpPr>
+          <p:cNvPr id="31" name="TextBox 30"/>
+          <p:cNvSpPr txBox="1"/>
+          <p:nvPr/>
+        </p:nvSpPr>
+        <p:spPr>
+          <a:xfrm>
+            <a:off x="8183879" y="4956048"/>
+            <a:ext cx="3319272" cy="256032"/>
           </a:xfrm>
           <a:prstGeom prst="rect">
             <a:avLst/>
@@ -10773,21 +10517,21 @@
                 </a:solidFill>
                 <a:latin typeface="Poppins"/>
               </a:rPr>
-              <a:t>DISCOUNT CODE</a:t>
-            </a:r>
-          </a:p>
-        </p:txBody>
-      </p:sp>
-      <p:sp>
-        <p:nvSpPr>
-          <p:cNvPr id="31" name="Rounded Rectangle 30"/>
+              <a:t>WITH DISCOUNT CODE</a:t>
+            </a:r>
+          </a:p>
+        </p:txBody>
+      </p:sp>
+      <p:sp>
+        <p:nvSpPr>
+          <p:cNvPr id="32" name="Rounded Rectangle 31"/>
           <p:cNvSpPr/>
           <p:nvPr/>
         </p:nvSpPr>
         <p:spPr>
           <a:xfrm>
-            <a:off x="8334756" y="4956048"/>
-            <a:ext cx="3017520" cy="548640"/>
+            <a:off x="8334756" y="5248656"/>
+            <a:ext cx="3017520" cy="530352"/>
           </a:xfrm>
           <a:prstGeom prst="roundRect">
             <a:avLst>
@@ -10824,14 +10568,14 @@
       </p:sp>
       <p:sp>
         <p:nvSpPr>
-          <p:cNvPr id="32" name="TextBox 31"/>
+          <p:cNvPr id="33" name="TextBox 32"/>
           <p:cNvSpPr txBox="1"/>
           <p:nvPr/>
         </p:nvSpPr>
         <p:spPr>
           <a:xfrm>
-            <a:off x="8334756" y="4956048"/>
-            <a:ext cx="3017520" cy="548640"/>
+            <a:off x="8334756" y="5248656"/>
+            <a:ext cx="3017520" cy="530352"/>
           </a:xfrm>
           <a:prstGeom prst="rect">
             <a:avLst/>
@@ -10863,14 +10607,14 @@
       </p:sp>
       <p:sp>
         <p:nvSpPr>
-          <p:cNvPr id="33" name="TextBox 32"/>
+          <p:cNvPr id="34" name="TextBox 33"/>
           <p:cNvSpPr txBox="1"/>
           <p:nvPr/>
         </p:nvSpPr>
         <p:spPr>
           <a:xfrm>
-            <a:off x="8183879" y="5623560"/>
-            <a:ext cx="3319272" cy="411480"/>
+            <a:off x="8183879" y="5833872"/>
+            <a:ext cx="3319272" cy="347472"/>
           </a:xfrm>
           <a:prstGeom prst="rect">
             <a:avLst/>
@@ -10895,14 +10639,14 @@
                 </a:solidFill>
                 <a:latin typeface="Poppins"/>
               </a:rPr>
-              <a:t>Use it at checkout on the KCD Porto event page</a:t>
-            </a:r>
-          </a:p>
-        </p:txBody>
-      </p:sp>
-      <p:sp>
-        <p:nvSpPr>
-          <p:cNvPr id="34" name="TextBox 33"/>
+              <a:t>10% off tickets at checkout on the KCD Porto event page</a:t>
+            </a:r>
+          </a:p>
+        </p:txBody>
+      </p:sp>
+      <p:sp>
+        <p:nvSpPr>
+          <p:cNvPr id="35" name="TextBox 34"/>
           <p:cNvSpPr txBox="1"/>
           <p:nvPr/>
         </p:nvSpPr>
@@ -10941,7 +10685,7 @@
       </p:sp>
       <p:sp>
         <p:nvSpPr>
-          <p:cNvPr id="35" name="TextBox 34"/>
+          <p:cNvPr id="36" name="TextBox 35"/>
           <p:cNvSpPr txBox="1"/>
           <p:nvPr/>
         </p:nvSpPr>

</xml_diff>